<commit_message>
Example deck: invented names for the players, the accomplices and the observers
Co-Authored-By: Claude Opus 5.5 <noreply@anthropic.com>
Claude-Session: https://claude.ai/code/session_01CADBrBabqHCmscSjsAhoYN
</commit_message>
<xml_diff>
--- a/docs/examples/example-crisis-exercise-deck.pptx
+++ b/docs/examples/example-crisis-exercise-deck.pptx
@@ -4510,9 +4510,10 @@
                 <a:tableStyleId>{5C22544A-7EE6-4342-B048-85BDC9FD1C3A}</a:tableStyleId>
               </a:tblPr>
               <a:tblGrid>
-                <a:gridCol w="3164000"/>
+                <a:gridCol w="2712000"/>
+                <a:gridCol w="1808000"/>
+                <a:gridCol w="2938000"/>
                 <a:gridCol w="3842000"/>
-                <a:gridCol w="4294000"/>
               </a:tblGrid>
               <a:tr h="260000">
                 <a:tc>
@@ -4528,6 +4529,28 @@
                           <a:latin typeface="Arial"/>
                         </a:rPr>
                         <a:t>Cell</a:t>
+                      </a:r>
+                    </a:p>
+                  </a:txBody>
+                  <a:tcPr>
+                    <a:solidFill>
+                      <a:srgbClr val="451DC7"/>
+                    </a:solidFill>
+                  </a:tcPr>
+                </a:tc>
+                <a:tc>
+                  <a:txBody>
+                    <a:bodyPr/>
+                    <a:lstStyle/>
+                    <a:p>
+                      <a:r>
+                        <a:rPr sz="900" b="1">
+                          <a:solidFill>
+                            <a:srgbClr val="FFFFFF"/>
+                          </a:solidFill>
+                          <a:latin typeface="Arial"/>
+                        </a:rPr>
+                        <a:t>Name</a:t>
                       </a:r>
                     </a:p>
                   </a:txBody>
@@ -4617,6 +4640,28 @@
                           </a:solidFill>
                           <a:latin typeface="Arial"/>
                         </a:rPr>
+                        <a:t>Helena Varga</a:t>
+                      </a:r>
+                    </a:p>
+                  </a:txBody>
+                  <a:tcPr>
+                    <a:solidFill>
+                      <a:srgbClr val="EEEAFB"/>
+                    </a:solidFill>
+                  </a:tcPr>
+                </a:tc>
+                <a:tc>
+                  <a:txBody>
+                    <a:bodyPr/>
+                    <a:lstStyle/>
+                    <a:p>
+                      <a:r>
+                        <a:rPr sz="900" b="0">
+                          <a:solidFill>
+                            <a:srgbClr val="211248"/>
+                          </a:solidFill>
+                          <a:latin typeface="Arial"/>
+                        </a:rPr>
                         <a:t>Group Chief Executive Officer</a:t>
                       </a:r>
                     </a:p>
@@ -4664,6 +4709,28 @@
                           <a:latin typeface="Arial"/>
                         </a:rPr>
                         <a:t>Decision cell (executive committee)</a:t>
+                      </a:r>
+                    </a:p>
+                  </a:txBody>
+                  <a:tcPr>
+                    <a:solidFill>
+                      <a:srgbClr val="FFFFFF"/>
+                    </a:solidFill>
+                  </a:tcPr>
+                </a:tc>
+                <a:tc>
+                  <a:txBody>
+                    <a:bodyPr/>
+                    <a:lstStyle/>
+                    <a:p>
+                      <a:r>
+                        <a:rPr sz="900" b="0">
+                          <a:solidFill>
+                            <a:srgbClr val="211248"/>
+                          </a:solidFill>
+                          <a:latin typeface="Arial"/>
+                        </a:rPr>
+                        <a:t>Marc Delorme</a:t>
                       </a:r>
                     </a:p>
                   </a:txBody>
@@ -4753,6 +4820,28 @@
                           </a:solidFill>
                           <a:latin typeface="Arial"/>
                         </a:rPr>
+                        <a:t>Aisha Rahman</a:t>
+                      </a:r>
+                    </a:p>
+                  </a:txBody>
+                  <a:tcPr>
+                    <a:solidFill>
+                      <a:srgbClr val="EEEAFB"/>
+                    </a:solidFill>
+                  </a:tcPr>
+                </a:tc>
+                <a:tc>
+                  <a:txBody>
+                    <a:bodyPr/>
+                    <a:lstStyle/>
+                    <a:p>
+                      <a:r>
+                        <a:rPr sz="900" b="0">
+                          <a:solidFill>
+                            <a:srgbClr val="211248"/>
+                          </a:solidFill>
+                          <a:latin typeface="Arial"/>
+                        </a:rPr>
                         <a:t>Chief Communications Officer</a:t>
                       </a:r>
                     </a:p>
@@ -4800,6 +4889,28 @@
                           <a:latin typeface="Arial"/>
                         </a:rPr>
                         <a:t>Decision cell (executive committee)</a:t>
+                      </a:r>
+                    </a:p>
+                  </a:txBody>
+                  <a:tcPr>
+                    <a:solidFill>
+                      <a:srgbClr val="FFFFFF"/>
+                    </a:solidFill>
+                  </a:tcPr>
+                </a:tc>
+                <a:tc>
+                  <a:txBody>
+                    <a:bodyPr/>
+                    <a:lstStyle/>
+                    <a:p>
+                      <a:r>
+                        <a:rPr sz="900" b="0">
+                          <a:solidFill>
+                            <a:srgbClr val="211248"/>
+                          </a:solidFill>
+                          <a:latin typeface="Arial"/>
+                        </a:rPr>
+                        <a:t>Tomas Lindqvist</a:t>
                       </a:r>
                     </a:p>
                   </a:txBody>
@@ -4889,6 +5000,28 @@
                           </a:solidFill>
                           <a:latin typeface="Arial"/>
                         </a:rPr>
+                        <a:t>Claire Moreau</a:t>
+                      </a:r>
+                    </a:p>
+                  </a:txBody>
+                  <a:tcPr>
+                    <a:solidFill>
+                      <a:srgbClr val="EEEAFB"/>
+                    </a:solidFill>
+                  </a:tcPr>
+                </a:tc>
+                <a:tc>
+                  <a:txBody>
+                    <a:bodyPr/>
+                    <a:lstStyle/>
+                    <a:p>
+                      <a:r>
+                        <a:rPr sz="900" b="0">
+                          <a:solidFill>
+                            <a:srgbClr val="211248"/>
+                          </a:solidFill>
+                          <a:latin typeface="Arial"/>
+                        </a:rPr>
                         <a:t>Chief Human Resources Officer</a:t>
                       </a:r>
                     </a:p>
@@ -4936,6 +5069,28 @@
                           <a:latin typeface="Arial"/>
                         </a:rPr>
                         <a:t>Decision cell (executive committee)</a:t>
+                      </a:r>
+                    </a:p>
+                  </a:txBody>
+                  <a:tcPr>
+                    <a:solidFill>
+                      <a:srgbClr val="FFFFFF"/>
+                    </a:solidFill>
+                  </a:tcPr>
+                </a:tc>
+                <a:tc>
+                  <a:txBody>
+                    <a:bodyPr/>
+                    <a:lstStyle/>
+                    <a:p>
+                      <a:r>
+                        <a:rPr sz="900" b="0">
+                          <a:solidFill>
+                            <a:srgbClr val="211248"/>
+                          </a:solidFill>
+                          <a:latin typeface="Arial"/>
+                        </a:rPr>
+                        <a:t>David Okonkwo</a:t>
                       </a:r>
                     </a:p>
                   </a:txBody>
@@ -5025,6 +5180,28 @@
                           </a:solidFill>
                           <a:latin typeface="Arial"/>
                         </a:rPr>
+                        <a:t>Nina Castellanos</a:t>
+                      </a:r>
+                    </a:p>
+                  </a:txBody>
+                  <a:tcPr>
+                    <a:solidFill>
+                      <a:srgbClr val="EEEAFB"/>
+                    </a:solidFill>
+                  </a:tcPr>
+                </a:tc>
+                <a:tc>
+                  <a:txBody>
+                    <a:bodyPr/>
+                    <a:lstStyle/>
+                    <a:p>
+                      <a:r>
+                        <a:rPr sz="900" b="0">
+                          <a:solidFill>
+                            <a:srgbClr val="211248"/>
+                          </a:solidFill>
+                          <a:latin typeface="Arial"/>
+                        </a:rPr>
                         <a:t>Group Chief Information Officer</a:t>
                       </a:r>
                     </a:p>
@@ -5072,6 +5249,28 @@
                           <a:latin typeface="Arial"/>
                         </a:rPr>
                         <a:t>Decision cell (executive committee)</a:t>
+                      </a:r>
+                    </a:p>
+                  </a:txBody>
+                  <a:tcPr>
+                    <a:solidFill>
+                      <a:srgbClr val="FFFFFF"/>
+                    </a:solidFill>
+                  </a:tcPr>
+                </a:tc>
+                <a:tc>
+                  <a:txBody>
+                    <a:bodyPr/>
+                    <a:lstStyle/>
+                    <a:p>
+                      <a:r>
+                        <a:rPr sz="900" b="0">
+                          <a:solidFill>
+                            <a:srgbClr val="211248"/>
+                          </a:solidFill>
+                          <a:latin typeface="Arial"/>
+                        </a:rPr>
+                        <a:t>Paul Werner, Sofia Brandt</a:t>
                       </a:r>
                     </a:p>
                   </a:txBody>
@@ -5307,9 +5506,10 @@
                 <a:tableStyleId>{5C22544A-7EE6-4342-B048-85BDC9FD1C3A}</a:tableStyleId>
               </a:tblPr>
               <a:tblGrid>
-                <a:gridCol w="2938000"/>
+                <a:gridCol w="2486000"/>
+                <a:gridCol w="1808000"/>
+                <a:gridCol w="3164000"/>
                 <a:gridCol w="3842000"/>
-                <a:gridCol w="4520000"/>
               </a:tblGrid>
               <a:tr h="260000">
                 <a:tc>
@@ -5325,6 +5525,28 @@
                           <a:latin typeface="Arial"/>
                         </a:rPr>
                         <a:t>Accomplice</a:t>
+                      </a:r>
+                    </a:p>
+                  </a:txBody>
+                  <a:tcPr>
+                    <a:solidFill>
+                      <a:srgbClr val="451DC7"/>
+                    </a:solidFill>
+                  </a:tcPr>
+                </a:tc>
+                <a:tc>
+                  <a:txBody>
+                    <a:bodyPr/>
+                    <a:lstStyle/>
+                    <a:p>
+                      <a:r>
+                        <a:rPr sz="900" b="1">
+                          <a:solidFill>
+                            <a:srgbClr val="FFFFFF"/>
+                          </a:solidFill>
+                          <a:latin typeface="Arial"/>
+                        </a:rPr>
+                        <a:t>Name</a:t>
                       </a:r>
                     </a:p>
                   </a:txBody>
@@ -5414,6 +5636,28 @@
                           </a:solidFill>
                           <a:latin typeface="Arial"/>
                         </a:rPr>
+                        <a:t>Julien Marchetti</a:t>
+                      </a:r>
+                    </a:p>
+                  </a:txBody>
+                  <a:tcPr>
+                    <a:solidFill>
+                      <a:srgbClr val="EEEAFB"/>
+                    </a:solidFill>
+                  </a:tcPr>
+                </a:tc>
+                <a:tc>
+                  <a:txBody>
+                    <a:bodyPr/>
+                    <a:lstStyle/>
+                    <a:p>
+                      <a:r>
+                        <a:rPr sz="900" b="0">
+                          <a:solidFill>
+                            <a:srgbClr val="211248"/>
+                          </a:solidFill>
+                          <a:latin typeface="Arial"/>
+                        </a:rPr>
                         <a:t>SOC team, internal cyber expert</a:t>
                       </a:r>
                     </a:p>
@@ -5461,6 +5705,28 @@
                           <a:latin typeface="Arial"/>
                         </a:rPr>
                         <a:t>Head of AI innovation</a:t>
+                      </a:r>
+                    </a:p>
+                  </a:txBody>
+                  <a:tcPr>
+                    <a:solidFill>
+                      <a:srgbClr val="FFFFFF"/>
+                    </a:solidFill>
+                  </a:tcPr>
+                </a:tc>
+                <a:tc>
+                  <a:txBody>
+                    <a:bodyPr/>
+                    <a:lstStyle/>
+                    <a:p>
+                      <a:r>
+                        <a:rPr sz="900" b="0">
+                          <a:solidFill>
+                            <a:srgbClr val="211248"/>
+                          </a:solidFill>
+                          <a:latin typeface="Arial"/>
+                        </a:rPr>
+                        <a:t>Priya Nair</a:t>
                       </a:r>
                     </a:p>
                   </a:txBody>
@@ -5550,6 +5816,28 @@
                           </a:solidFill>
                           <a:latin typeface="Arial"/>
                         </a:rPr>
+                        <a:t>Oliver Grant</a:t>
+                      </a:r>
+                    </a:p>
+                  </a:txBody>
+                  <a:tcPr>
+                    <a:solidFill>
+                      <a:srgbClr val="EEEAFB"/>
+                    </a:solidFill>
+                  </a:tcPr>
+                </a:tc>
+                <a:tc>
+                  <a:txBody>
+                    <a:bodyPr/>
+                    <a:lstStyle/>
+                    <a:p>
+                      <a:r>
+                        <a:rPr sz="900" b="0">
+                          <a:solidFill>
+                            <a:srgbClr val="211248"/>
+                          </a:solidFill>
+                          <a:latin typeface="Arial"/>
+                        </a:rPr>
                         <a:t>Customer, competitor, partner</a:t>
                       </a:r>
                     </a:p>
@@ -5618,6 +5906,28 @@
                           </a:solidFill>
                           <a:latin typeface="Arial"/>
                         </a:rPr>
+                        <a:t>Lea Fontaine</a:t>
+                      </a:r>
+                    </a:p>
+                  </a:txBody>
+                  <a:tcPr>
+                    <a:solidFill>
+                      <a:srgbClr val="FFFFFF"/>
+                    </a:solidFill>
+                  </a:tcPr>
+                </a:tc>
+                <a:tc>
+                  <a:txBody>
+                    <a:bodyPr/>
+                    <a:lstStyle/>
+                    <a:p>
+                      <a:r>
+                        <a:rPr sz="900" b="0">
+                          <a:solidFill>
+                            <a:srgbClr val="211248"/>
+                          </a:solidFill>
+                          <a:latin typeface="Arial"/>
+                        </a:rPr>
                         <a:t>Journalist, social media</a:t>
                       </a:r>
                     </a:p>
@@ -5685,7 +5995,7 @@
                 </a:solidFill>
                 <a:latin typeface="Arial"/>
               </a:rPr>
-              <a:t>Observers: two cyber experts (facilitation) and one observer from risk management.</a:t>
+              <a:t>Observers: two cyber experts, Hugo Lambert and Mei Tanaka (facilitation), and Rachel Stein from risk management.</a:t>
             </a:r>
           </a:p>
           <a:p>

</xml_diff>